<commit_message>
Update Computer Network Title Presentation.pptx
</commit_message>
<xml_diff>
--- a/Projects/Computer Networks/Computer Network Title Presentation.pptx
+++ b/Projects/Computer Networks/Computer Network Title Presentation.pptx
@@ -5,7 +5,7 @@
     <p:sldMasterId id="2147483685" r:id="rId1"/>
   </p:sldMasterIdLst>
   <p:notesMasterIdLst>
-    <p:notesMasterId r:id="rId10"/>
+    <p:notesMasterId r:id="rId11"/>
   </p:notesMasterIdLst>
   <p:sldIdLst>
     <p:sldId id="261" r:id="rId2"/>
@@ -13,9 +13,10 @@
     <p:sldId id="259" r:id="rId4"/>
     <p:sldId id="256" r:id="rId5"/>
     <p:sldId id="262" r:id="rId6"/>
-    <p:sldId id="263" r:id="rId7"/>
-    <p:sldId id="264" r:id="rId8"/>
-    <p:sldId id="265" r:id="rId9"/>
+    <p:sldId id="267" r:id="rId7"/>
+    <p:sldId id="263" r:id="rId8"/>
+    <p:sldId id="264" r:id="rId9"/>
+    <p:sldId id="265" r:id="rId10"/>
   </p:sldIdLst>
   <p:sldSz cx="12192000" cy="6858000"/>
   <p:notesSz cx="6858000" cy="9144000"/>
@@ -11097,7 +11098,7 @@
         </p:nvSpPr>
         <p:spPr>
           <a:xfrm>
-            <a:off x="-220" y="146073"/>
+            <a:off x="-16848" y="206259"/>
             <a:ext cx="5831432" cy="1285067"/>
           </a:xfrm>
         </p:spPr>
@@ -11112,16 +11113,9 @@
                 <a:latin typeface="Times New Roman"/>
                 <a:cs typeface="Times New Roman"/>
               </a:rPr>
-              <a:t>Failover Network Using Redundant </a:t>
+              <a:t>Failover Network Using Redundant paths</a:t>
             </a:r>
-            <a:r>
-              <a:rPr lang="en-US" sz="4800">
-                <a:latin typeface="Times New Roman"/>
-                <a:cs typeface="Times New Roman"/>
-              </a:rPr>
-              <a:t>paths</a:t>
-            </a:r>
-            <a:endParaRPr lang="en-US" sz="4800" err="1">
+            <a:endParaRPr lang="en-US" sz="4800" dirty="0">
               <a:solidFill>
                 <a:schemeClr val="bg1"/>
               </a:solidFill>
@@ -21217,8 +21211,8 @@
         </p:nvSpPr>
         <p:spPr>
           <a:xfrm>
-            <a:off x="6773522" y="973414"/>
-            <a:ext cx="4307527" cy="4517136"/>
+            <a:off x="6430881" y="1170432"/>
+            <a:ext cx="5056013" cy="4517136"/>
           </a:xfrm>
         </p:spPr>
         <p:txBody>
@@ -21231,34 +21225,46 @@
               <a:buNone/>
             </a:pPr>
             <a:r>
-              <a:rPr lang="en-US" b="1" dirty="0">
+              <a:rPr lang="en-US" sz="2200" b="1" u="sng" dirty="0">
+                <a:latin typeface="Times New Roman" panose="02020603050405020304" pitchFamily="18" charset="0"/>
                 <a:ea typeface="+mn-lt"/>
-                <a:cs typeface="+mn-lt"/>
+                <a:cs typeface="Times New Roman" panose="02020603050405020304" pitchFamily="18" charset="0"/>
               </a:rPr>
               <a:t>STP (Spanning Tree Protocol)</a:t>
             </a:r>
-            <a:endParaRPr lang="en-US" dirty="0"/>
+            <a:endParaRPr lang="en-US" sz="2200" b="1" u="sng" dirty="0">
+              <a:latin typeface="Times New Roman" panose="02020603050405020304" pitchFamily="18" charset="0"/>
+              <a:cs typeface="Times New Roman" panose="02020603050405020304" pitchFamily="18" charset="0"/>
+            </a:endParaRPr>
           </a:p>
           <a:p>
             <a:pPr algn="just"/>
             <a:r>
-              <a:rPr lang="en-US" sz="1800" dirty="0">
+              <a:rPr lang="en-US" sz="2200" dirty="0">
+                <a:latin typeface="Times New Roman" panose="02020603050405020304" pitchFamily="18" charset="0"/>
                 <a:ea typeface="+mn-lt"/>
-                <a:cs typeface="+mn-lt"/>
+                <a:cs typeface="Times New Roman" panose="02020603050405020304" pitchFamily="18" charset="0"/>
               </a:rPr>
-              <a:t> </a:t>
+              <a:t> STP is a network protocol used to prevent looping within a network topology.</a:t>
             </a:r>
-            <a:r>
-              <a:rPr lang="en-US" dirty="0">
-                <a:ea typeface="+mn-lt"/>
-                <a:cs typeface="+mn-lt"/>
-              </a:rPr>
-              <a:t>STP is a network protocol used to prevent looping within a network topology. STP was created to avoid the problems that arise when computers exchange data on a local area network (LAN) that contains redundant paths.</a:t>
-            </a:r>
-            <a:endParaRPr lang="en-US" dirty="0"/>
           </a:p>
           <a:p>
-            <a:endParaRPr lang="en-US" sz="1800" dirty="0"/>
+            <a:pPr algn="just"/>
+            <a:r>
+              <a:rPr lang="en-US" sz="2200" dirty="0">
+                <a:latin typeface="Times New Roman" panose="02020603050405020304" pitchFamily="18" charset="0"/>
+                <a:ea typeface="+mn-lt"/>
+                <a:cs typeface="Times New Roman" panose="02020603050405020304" pitchFamily="18" charset="0"/>
+              </a:rPr>
+              <a:t> STP was created to avoid the problems that arise when computers exchange data on a local area network (LAN) that contains redundant paths.</a:t>
+            </a:r>
+            <a:endParaRPr lang="en-US" sz="2200" dirty="0">
+              <a:latin typeface="Times New Roman" panose="02020603050405020304" pitchFamily="18" charset="0"/>
+              <a:cs typeface="Times New Roman" panose="02020603050405020304" pitchFamily="18" charset="0"/>
+            </a:endParaRPr>
+          </a:p>
+          <a:p>
+            <a:endParaRPr lang="en-US" dirty="0"/>
           </a:p>
           <a:p>
             <a:endParaRPr lang="en-US" sz="1800" dirty="0"/>
@@ -21287,8 +21293,8 @@
         </p:blipFill>
         <p:spPr>
           <a:xfrm>
-            <a:off x="608342" y="1472691"/>
-            <a:ext cx="6000750" cy="4257675"/>
+            <a:off x="595039" y="1529400"/>
+            <a:ext cx="6000750" cy="3988995"/>
           </a:xfrm>
           <a:prstGeom prst="rect">
             <a:avLst/>
@@ -21324,6 +21330,41 @@
           </a:p>
         </p:txBody>
       </p:sp>
+      <p:sp>
+        <p:nvSpPr>
+          <p:cNvPr id="4" name="TextBox 3">
+            <a:extLst>
+              <a:ext uri="{FF2B5EF4-FFF2-40B4-BE49-F238E27FC236}">
+                <a16:creationId xmlns:a16="http://schemas.microsoft.com/office/drawing/2014/main" id="{0289F277-9E69-A18E-DFDA-23006C2EAD08}"/>
+              </a:ext>
+            </a:extLst>
+          </p:cNvPr>
+          <p:cNvSpPr txBox="1"/>
+          <p:nvPr/>
+        </p:nvSpPr>
+        <p:spPr>
+          <a:xfrm>
+            <a:off x="2306595" y="5730366"/>
+            <a:ext cx="2727029" cy="369332"/>
+          </a:xfrm>
+          <a:prstGeom prst="rect">
+            <a:avLst/>
+          </a:prstGeom>
+          <a:noFill/>
+        </p:spPr>
+        <p:txBody>
+          <a:bodyPr wrap="none" rtlCol="0">
+            <a:spAutoFit/>
+          </a:bodyPr>
+          <a:lstStyle/>
+          <a:p>
+            <a:r>
+              <a:rPr lang="en-US" dirty="0"/>
+              <a:t>Fig 2 : Broadcast Storm</a:t>
+            </a:r>
+          </a:p>
+        </p:txBody>
+      </p:sp>
     </p:spTree>
     <p:extLst>
       <p:ext uri="{BB962C8B-B14F-4D97-AF65-F5344CB8AC3E}">
@@ -21338,6 +21379,386 @@
 </file>
 
 <file path=ppt/slides/slide6.xml><?xml version="1.0" encoding="utf-8"?>
+<p:sld xmlns:a="http://schemas.openxmlformats.org/drawingml/2006/main" xmlns:r="http://schemas.openxmlformats.org/officeDocument/2006/relationships" xmlns:p="http://schemas.openxmlformats.org/presentationml/2006/main">
+  <p:cSld>
+    <p:bg>
+      <p:bgPr>
+        <a:solidFill>
+          <a:schemeClr val="bg1"/>
+        </a:solidFill>
+        <a:effectLst/>
+      </p:bgPr>
+    </p:bg>
+    <p:spTree>
+      <p:nvGrpSpPr>
+        <p:cNvPr id="1" name="">
+          <a:extLst>
+            <a:ext uri="{FF2B5EF4-FFF2-40B4-BE49-F238E27FC236}">
+              <a16:creationId xmlns:a16="http://schemas.microsoft.com/office/drawing/2014/main" id="{9BEE8821-FBA3-EBD8-BBF3-3BD9ABDBD384}"/>
+            </a:ext>
+          </a:extLst>
+        </p:cNvPr>
+        <p:cNvGrpSpPr/>
+        <p:nvPr/>
+      </p:nvGrpSpPr>
+      <p:grpSpPr>
+        <a:xfrm>
+          <a:off x="0" y="0"/>
+          <a:ext cx="0" cy="0"/>
+          <a:chOff x="0" y="0"/>
+          <a:chExt cx="0" cy="0"/>
+        </a:xfrm>
+      </p:grpSpPr>
+      <p:sp useBgFill="1">
+        <p:nvSpPr>
+          <p:cNvPr id="29" name="Rectangle 28">
+            <a:extLst>
+              <a:ext uri="{FF2B5EF4-FFF2-40B4-BE49-F238E27FC236}">
+                <a16:creationId xmlns:a16="http://schemas.microsoft.com/office/drawing/2014/main" id="{B7473BF3-6C9B-02EE-8745-086C8508354C}"/>
+              </a:ext>
+              <a:ext uri="{C183D7F6-B498-43B3-948B-1728B52AA6E4}">
+                <adec:decorative xmlns:adec="http://schemas.microsoft.com/office/drawing/2017/decorative" val="1"/>
+              </a:ext>
+            </a:extLst>
+          </p:cNvPr>
+          <p:cNvSpPr>
+            <a:spLocks noGrp="1" noRot="1" noChangeAspect="1" noMove="1" noResize="1" noEditPoints="1" noAdjustHandles="1" noChangeArrowheads="1" noChangeShapeType="1" noTextEdit="1"/>
+          </p:cNvSpPr>
+          <p:nvPr>
+            <p:extLst>
+              <p:ext uri="{386F3935-93C4-4BCD-93E2-E3B085C9AB24}">
+                <p16:designElem xmlns:p16="http://schemas.microsoft.com/office/powerpoint/2015/main" val="1"/>
+              </p:ext>
+            </p:extLst>
+          </p:nvPr>
+        </p:nvSpPr>
+        <p:spPr>
+          <a:xfrm>
+            <a:off x="0" y="0"/>
+            <a:ext cx="12192000" cy="6858000"/>
+          </a:xfrm>
+          <a:prstGeom prst="rect">
+            <a:avLst/>
+          </a:prstGeom>
+          <a:ln w="12700" cap="flat" cmpd="sng" algn="ctr">
+            <a:noFill/>
+            <a:prstDash val="solid"/>
+            <a:miter lim="800000"/>
+          </a:ln>
+          <a:effectLst/>
+          <a:extLst>
+            <a:ext uri="{91240B29-F687-4F45-9708-019B960494DF}">
+              <a14:hiddenLine xmlns:a14="http://schemas.microsoft.com/office/drawing/2010/main" w="12700" cap="flat" cmpd="sng" algn="ctr">
+                <a:solidFill>
+                  <a:schemeClr val="accent1">
+                    <a:shade val="15000"/>
+                  </a:schemeClr>
+                </a:solidFill>
+                <a:prstDash val="solid"/>
+                <a:miter lim="800000"/>
+              </a14:hiddenLine>
+            </a:ext>
+          </a:extLst>
+        </p:spPr>
+        <p:style>
+          <a:lnRef idx="2">
+            <a:schemeClr val="accent1">
+              <a:shade val="15000"/>
+            </a:schemeClr>
+          </a:lnRef>
+          <a:fillRef idx="1">
+            <a:schemeClr val="accent1"/>
+          </a:fillRef>
+          <a:effectRef idx="0">
+            <a:schemeClr val="accent1"/>
+          </a:effectRef>
+          <a:fontRef idx="minor">
+            <a:schemeClr val="lt1"/>
+          </a:fontRef>
+        </p:style>
+        <p:txBody>
+          <a:bodyPr rtlCol="0" anchor="ctr"/>
+          <a:lstStyle/>
+          <a:p>
+            <a:pPr algn="ctr"/>
+            <a:endParaRPr lang="en-US"/>
+          </a:p>
+        </p:txBody>
+      </p:sp>
+      <p:sp>
+        <p:nvSpPr>
+          <p:cNvPr id="2" name="Title 1">
+            <a:extLst>
+              <a:ext uri="{FF2B5EF4-FFF2-40B4-BE49-F238E27FC236}">
+                <a16:creationId xmlns:a16="http://schemas.microsoft.com/office/drawing/2014/main" id="{9759BD6A-5123-CB58-2508-89EA9C81827F}"/>
+              </a:ext>
+            </a:extLst>
+          </p:cNvPr>
+          <p:cNvSpPr>
+            <a:spLocks noGrp="1"/>
+          </p:cNvSpPr>
+          <p:nvPr>
+            <p:ph type="title"/>
+          </p:nvPr>
+        </p:nvSpPr>
+        <p:spPr>
+          <a:xfrm>
+            <a:off x="614678" y="548640"/>
+            <a:ext cx="10872216" cy="1133856"/>
+          </a:xfrm>
+        </p:spPr>
+        <p:txBody>
+          <a:bodyPr anchor="t">
+            <a:normAutofit/>
+          </a:bodyPr>
+          <a:lstStyle/>
+          <a:p>
+            <a:r>
+              <a:rPr lang="en-US" dirty="0"/>
+              <a:t>Background Study</a:t>
+            </a:r>
+          </a:p>
+        </p:txBody>
+      </p:sp>
+      <p:sp>
+        <p:nvSpPr>
+          <p:cNvPr id="3" name="Content Placeholder 2">
+            <a:extLst>
+              <a:ext uri="{FF2B5EF4-FFF2-40B4-BE49-F238E27FC236}">
+                <a16:creationId xmlns:a16="http://schemas.microsoft.com/office/drawing/2014/main" id="{3DFAA015-528A-B849-5DCD-80EB425A120F}"/>
+              </a:ext>
+            </a:extLst>
+          </p:cNvPr>
+          <p:cNvSpPr>
+            <a:spLocks noGrp="1"/>
+          </p:cNvSpPr>
+          <p:nvPr>
+            <p:ph idx="1"/>
+          </p:nvPr>
+        </p:nvSpPr>
+        <p:spPr>
+          <a:xfrm>
+            <a:off x="6584387" y="967933"/>
+            <a:ext cx="5047775" cy="4517136"/>
+          </a:xfrm>
+        </p:spPr>
+        <p:txBody>
+          <a:bodyPr vert="horz" lIns="91440" tIns="45720" rIns="91440" bIns="45720" rtlCol="0" anchor="t">
+            <a:normAutofit fontScale="92500"/>
+          </a:bodyPr>
+          <a:lstStyle/>
+          <a:p>
+            <a:pPr marL="0" indent="0">
+              <a:buNone/>
+            </a:pPr>
+            <a:r>
+              <a:rPr lang="en-US" sz="2400" b="1" u="sng" dirty="0">
+                <a:latin typeface="Times New Roman" panose="02020603050405020304" pitchFamily="18" charset="0"/>
+                <a:ea typeface="+mn-lt"/>
+                <a:cs typeface="Times New Roman" panose="02020603050405020304" pitchFamily="18" charset="0"/>
+              </a:rPr>
+              <a:t>STP (Spanning Tree Protocol)</a:t>
+            </a:r>
+            <a:endParaRPr lang="en-US" sz="2400" u="sng" dirty="0">
+              <a:latin typeface="Times New Roman" panose="02020603050405020304" pitchFamily="18" charset="0"/>
+              <a:cs typeface="Times New Roman" panose="02020603050405020304" pitchFamily="18" charset="0"/>
+            </a:endParaRPr>
+          </a:p>
+          <a:p>
+            <a:pPr algn="just"/>
+            <a:r>
+              <a:rPr lang="en-US" sz="2400" dirty="0">
+                <a:solidFill>
+                  <a:schemeClr val="tx1">
+                    <a:lumMod val="95000"/>
+                    <a:lumOff val="5000"/>
+                  </a:schemeClr>
+                </a:solidFill>
+                <a:latin typeface="Times New Roman" panose="02020603050405020304" pitchFamily="18" charset="0"/>
+                <a:cs typeface="Times New Roman" panose="02020603050405020304" pitchFamily="18" charset="0"/>
+              </a:rPr>
+              <a:t>STP uses the spanning tree algorithm to prevent loops.</a:t>
+            </a:r>
+          </a:p>
+          <a:p>
+            <a:pPr algn="just"/>
+            <a:r>
+              <a:rPr lang="en-US" sz="2400" dirty="0">
+                <a:solidFill>
+                  <a:schemeClr val="tx1">
+                    <a:lumMod val="95000"/>
+                    <a:lumOff val="5000"/>
+                  </a:schemeClr>
+                </a:solidFill>
+                <a:latin typeface="Times New Roman" panose="02020603050405020304" pitchFamily="18" charset="0"/>
+                <a:cs typeface="Times New Roman" panose="02020603050405020304" pitchFamily="18" charset="0"/>
+              </a:rPr>
+              <a:t>In the topology above, STP has placed one port on SW3 in the blocking state.</a:t>
+            </a:r>
+          </a:p>
+          <a:p>
+            <a:pPr algn="just"/>
+            <a:r>
+              <a:rPr lang="en-US" sz="2400" dirty="0">
+                <a:solidFill>
+                  <a:schemeClr val="tx1">
+                    <a:lumMod val="95000"/>
+                    <a:lumOff val="5000"/>
+                  </a:schemeClr>
+                </a:solidFill>
+                <a:latin typeface="Times New Roman" panose="02020603050405020304" pitchFamily="18" charset="0"/>
+                <a:cs typeface="Times New Roman" panose="02020603050405020304" pitchFamily="18" charset="0"/>
+              </a:rPr>
+              <a:t> That port will no longer process any frames except the STP messages. If SW3 receives a broadcast frame from SW1, it will not forward it out to the port connected to SW2</a:t>
+            </a:r>
+            <a:r>
+              <a:rPr lang="en-US" sz="2400" dirty="0">
+                <a:solidFill>
+                  <a:schemeClr val="tx1">
+                    <a:lumMod val="95000"/>
+                    <a:lumOff val="5000"/>
+                  </a:schemeClr>
+                </a:solidFill>
+              </a:rPr>
+              <a:t>.</a:t>
+            </a:r>
+          </a:p>
+          <a:p>
+            <a:pPr marL="0" indent="0">
+              <a:buNone/>
+            </a:pPr>
+            <a:endParaRPr lang="en-US" sz="1800" dirty="0"/>
+          </a:p>
+          <a:p>
+            <a:endParaRPr lang="en-US" sz="1800" dirty="0"/>
+          </a:p>
+        </p:txBody>
+      </p:sp>
+      <p:sp>
+        <p:nvSpPr>
+          <p:cNvPr id="7" name="Slide Number Placeholder 6">
+            <a:extLst>
+              <a:ext uri="{FF2B5EF4-FFF2-40B4-BE49-F238E27FC236}">
+                <a16:creationId xmlns:a16="http://schemas.microsoft.com/office/drawing/2014/main" id="{E83BD210-4373-2659-8D5D-C2B3C5309B56}"/>
+              </a:ext>
+            </a:extLst>
+          </p:cNvPr>
+          <p:cNvSpPr>
+            <a:spLocks noGrp="1"/>
+          </p:cNvSpPr>
+          <p:nvPr>
+            <p:ph type="sldNum" sz="quarter" idx="12"/>
+          </p:nvPr>
+        </p:nvSpPr>
+        <p:spPr/>
+        <p:txBody>
+          <a:bodyPr/>
+          <a:lstStyle/>
+          <a:p>
+            <a:fld id="{CC057153-B650-4DEB-B370-79DDCFDCE934}" type="slidenum">
+              <a:rPr lang="en-US" smtClean="0"/>
+              <a:t>6</a:t>
+            </a:fld>
+            <a:endParaRPr lang="en-US"/>
+          </a:p>
+        </p:txBody>
+      </p:sp>
+      <p:sp>
+        <p:nvSpPr>
+          <p:cNvPr id="4" name="TextBox 3">
+            <a:extLst>
+              <a:ext uri="{FF2B5EF4-FFF2-40B4-BE49-F238E27FC236}">
+                <a16:creationId xmlns:a16="http://schemas.microsoft.com/office/drawing/2014/main" id="{AD3D8C4B-8AA1-942C-E543-C6FCBEE2518A}"/>
+              </a:ext>
+            </a:extLst>
+          </p:cNvPr>
+          <p:cNvSpPr txBox="1"/>
+          <p:nvPr/>
+        </p:nvSpPr>
+        <p:spPr>
+          <a:xfrm>
+            <a:off x="1278592" y="5730366"/>
+            <a:ext cx="4660250" cy="369332"/>
+          </a:xfrm>
+          <a:prstGeom prst="rect">
+            <a:avLst/>
+          </a:prstGeom>
+          <a:noFill/>
+        </p:spPr>
+        <p:txBody>
+          <a:bodyPr wrap="none" rtlCol="0">
+            <a:spAutoFit/>
+          </a:bodyPr>
+          <a:lstStyle/>
+          <a:p>
+            <a:r>
+              <a:rPr lang="en-US" dirty="0"/>
+              <a:t>Fig 3 : With Spanning Tree Protocol (STP)</a:t>
+            </a:r>
+          </a:p>
+        </p:txBody>
+      </p:sp>
+      <p:pic>
+        <p:nvPicPr>
+          <p:cNvPr id="1026" name="Picture 2" descr="stp topology blocked port">
+            <a:extLst>
+              <a:ext uri="{FF2B5EF4-FFF2-40B4-BE49-F238E27FC236}">
+                <a16:creationId xmlns:a16="http://schemas.microsoft.com/office/drawing/2014/main" id="{9510F8FC-48A5-D3BE-FFA9-730A4F93554F}"/>
+              </a:ext>
+            </a:extLst>
+          </p:cNvPr>
+          <p:cNvPicPr>
+            <a:picLocks noChangeAspect="1" noChangeArrowheads="1"/>
+          </p:cNvPicPr>
+          <p:nvPr/>
+        </p:nvPicPr>
+        <p:blipFill>
+          <a:blip r:embed="rId2">
+            <a:extLst>
+              <a:ext uri="{28A0092B-C50C-407E-A947-70E740481C1C}">
+                <a14:useLocalDpi xmlns:a14="http://schemas.microsoft.com/office/drawing/2010/main" val="0"/>
+              </a:ext>
+            </a:extLst>
+          </a:blip>
+          <a:srcRect/>
+          <a:stretch>
+            <a:fillRect/>
+          </a:stretch>
+        </p:blipFill>
+        <p:spPr bwMode="auto">
+          <a:xfrm>
+            <a:off x="524211" y="1422689"/>
+            <a:ext cx="6169012" cy="3876308"/>
+          </a:xfrm>
+          <a:prstGeom prst="rect">
+            <a:avLst/>
+          </a:prstGeom>
+          <a:noFill/>
+          <a:extLst>
+            <a:ext uri="{909E8E84-426E-40DD-AFC4-6F175D3DCCD1}">
+              <a14:hiddenFill xmlns:a14="http://schemas.microsoft.com/office/drawing/2010/main">
+                <a:solidFill>
+                  <a:srgbClr val="FFFFFF"/>
+                </a:solidFill>
+              </a14:hiddenFill>
+            </a:ext>
+          </a:extLst>
+        </p:spPr>
+      </p:pic>
+    </p:spTree>
+    <p:extLst>
+      <p:ext uri="{BB962C8B-B14F-4D97-AF65-F5344CB8AC3E}">
+        <p14:creationId xmlns:p14="http://schemas.microsoft.com/office/powerpoint/2010/main" val="3177933657"/>
+      </p:ext>
+    </p:extLst>
+  </p:cSld>
+  <p:clrMapOvr>
+    <a:masterClrMapping/>
+  </p:clrMapOvr>
+</p:sld>
+</file>
+
+<file path=ppt/slides/slide7.xml><?xml version="1.0" encoding="utf-8"?>
 <p:sld xmlns:a="http://schemas.openxmlformats.org/drawingml/2006/main" xmlns:r="http://schemas.openxmlformats.org/officeDocument/2006/relationships" xmlns:p="http://schemas.openxmlformats.org/presentationml/2006/main">
   <p:cSld>
     <p:spTree>
@@ -21420,15 +21841,18 @@
           </a:bodyPr>
           <a:lstStyle/>
           <a:p>
+            <a:pPr marL="0" indent="0">
+              <a:buNone/>
+            </a:pPr>
             <a:r>
-              <a:rPr lang="en-US" sz="2400" b="1" dirty="0">
+              <a:rPr lang="en-US" sz="2400" b="1" u="sng" dirty="0">
                 <a:latin typeface="Times New Roman"/>
                 <a:ea typeface="+mn-lt"/>
                 <a:cs typeface="+mn-lt"/>
               </a:rPr>
               <a:t>HSRP(Hot Standby Router Protocol)</a:t>
             </a:r>
-            <a:endParaRPr lang="en-US" sz="2400" b="1" dirty="0">
+            <a:endParaRPr lang="en-US" sz="2400" b="1" u="sng" dirty="0">
               <a:latin typeface="Times New Roman"/>
             </a:endParaRPr>
           </a:p>
@@ -21455,7 +21879,7 @@
                 <a:ea typeface="+mn-lt"/>
                 <a:cs typeface="+mn-lt"/>
               </a:rPr>
-              <a:t>In this protocol , one of the routers is selected to be the active router and another to be the standby router, which assumes control of the designated active router fail.</a:t>
+              <a:t>In this protocol, one of the routers is selected to be the active router and another to be the standby router, which assumes control of the designated active router fail.</a:t>
             </a:r>
             <a:endParaRPr lang="en-US" sz="2400" dirty="0">
               <a:latin typeface="Times New Roman"/>
@@ -21502,7 +21926,7 @@
           <a:p>
             <a:fld id="{CC057153-B650-4DEB-B370-79DDCFDCE934}" type="slidenum">
               <a:rPr lang="en-US" smtClean="0"/>
-              <a:t>6</a:t>
+              <a:t>7</a:t>
             </a:fld>
             <a:endParaRPr lang="en-US"/>
           </a:p>
@@ -21575,7 +21999,7 @@
 </p:sld>
 </file>
 
-<file path=ppt/slides/slide7.xml><?xml version="1.0" encoding="utf-8"?>
+<file path=ppt/slides/slide8.xml><?xml version="1.0" encoding="utf-8"?>
 <p:sld xmlns:a="http://schemas.openxmlformats.org/drawingml/2006/main" xmlns:r="http://schemas.openxmlformats.org/officeDocument/2006/relationships" xmlns:p="http://schemas.openxmlformats.org/presentationml/2006/main">
   <p:cSld>
     <p:spTree>
@@ -21769,7 +22193,19 @@
                 <a:ea typeface="+mn-lt"/>
                 <a:cs typeface="+mn-lt"/>
               </a:rPr>
-              <a:t>Each router is Standby (Backup) for the alternative groups.</a:t>
+              <a:t>Each router is Standby (Backup) for the </a:t>
+            </a:r>
+          </a:p>
+          <a:p>
+            <a:pPr marL="0" indent="0" algn="just">
+              <a:buNone/>
+            </a:pPr>
+            <a:r>
+              <a:rPr lang="en-US" sz="2400" dirty="0">
+                <a:ea typeface="+mn-lt"/>
+                <a:cs typeface="+mn-lt"/>
+              </a:rPr>
+              <a:t>	alternative groups.</a:t>
             </a:r>
             <a:endParaRPr lang="en-US" dirty="0"/>
           </a:p>
@@ -21821,12 +22257,59 @@
           <a:p>
             <a:fld id="{CC057153-B650-4DEB-B370-79DDCFDCE934}" type="slidenum">
               <a:rPr lang="en-US" smtClean="0"/>
-              <a:t>7</a:t>
+              <a:t>8</a:t>
             </a:fld>
             <a:endParaRPr lang="en-US"/>
           </a:p>
         </p:txBody>
       </p:sp>
+      <p:pic>
+        <p:nvPicPr>
+          <p:cNvPr id="1026" name="Picture 2" descr="Solved: MHSRP and IP SLA - Cisco Community">
+            <a:extLst>
+              <a:ext uri="{FF2B5EF4-FFF2-40B4-BE49-F238E27FC236}">
+                <a16:creationId xmlns:a16="http://schemas.microsoft.com/office/drawing/2014/main" id="{EFA5C8D1-3470-74B9-BAFC-5A6EB619D930}"/>
+              </a:ext>
+            </a:extLst>
+          </p:cNvPr>
+          <p:cNvPicPr>
+            <a:picLocks noChangeAspect="1" noChangeArrowheads="1"/>
+          </p:cNvPicPr>
+          <p:nvPr/>
+        </p:nvPicPr>
+        <p:blipFill>
+          <a:blip r:embed="rId2">
+            <a:extLst>
+              <a:ext uri="{28A0092B-C50C-407E-A947-70E740481C1C}">
+                <a14:useLocalDpi xmlns:a14="http://schemas.microsoft.com/office/drawing/2010/main" val="0"/>
+              </a:ext>
+            </a:extLst>
+          </a:blip>
+          <a:srcRect/>
+          <a:stretch>
+            <a:fillRect/>
+          </a:stretch>
+        </p:blipFill>
+        <p:spPr bwMode="auto">
+          <a:xfrm>
+            <a:off x="7345707" y="2942263"/>
+            <a:ext cx="4088412" cy="3582757"/>
+          </a:xfrm>
+          <a:prstGeom prst="rect">
+            <a:avLst/>
+          </a:prstGeom>
+          <a:noFill/>
+          <a:extLst>
+            <a:ext uri="{909E8E84-426E-40DD-AFC4-6F175D3DCCD1}">
+              <a14:hiddenFill xmlns:a14="http://schemas.microsoft.com/office/drawing/2010/main">
+                <a:solidFill>
+                  <a:srgbClr val="FFFFFF"/>
+                </a:solidFill>
+              </a14:hiddenFill>
+            </a:ext>
+          </a:extLst>
+        </p:spPr>
+      </p:pic>
     </p:spTree>
     <p:extLst>
       <p:ext uri="{BB962C8B-B14F-4D97-AF65-F5344CB8AC3E}">
@@ -21840,7 +22323,7 @@
 </p:sld>
 </file>
 
-<file path=ppt/slides/slide8.xml><?xml version="1.0" encoding="utf-8"?>
+<file path=ppt/slides/slide9.xml><?xml version="1.0" encoding="utf-8"?>
 <p:sld xmlns:a="http://schemas.openxmlformats.org/drawingml/2006/main" xmlns:r="http://schemas.openxmlformats.org/officeDocument/2006/relationships" xmlns:p="http://schemas.openxmlformats.org/presentationml/2006/main">
   <p:cSld>
     <p:bg>
@@ -22078,7 +22561,7 @@
           <a:p>
             <a:fld id="{CC057153-B650-4DEB-B370-79DDCFDCE934}" type="slidenum">
               <a:rPr lang="en-US" smtClean="0"/>
-              <a:t>8</a:t>
+              <a:t>9</a:t>
             </a:fld>
             <a:endParaRPr lang="en-US"/>
           </a:p>

</xml_diff>